<commit_message>
This is our final Task 4
</commit_message>
<xml_diff>
--- a/TASK 4/Group16 Task4.pptx
+++ b/TASK 4/Group16 Task4.pptx
@@ -5,7 +5,7 @@
     <p:sldMasterId id="2147483648" r:id="rId1"/>
   </p:sldMasterIdLst>
   <p:notesMasterIdLst>
-    <p:notesMasterId r:id="rId15"/>
+    <p:notesMasterId r:id="rId16"/>
   </p:notesMasterIdLst>
   <p:sldIdLst>
     <p:sldId id="256" r:id="rId2"/>
@@ -14,13 +14,14 @@
     <p:sldId id="259" r:id="rId5"/>
     <p:sldId id="261" r:id="rId6"/>
     <p:sldId id="262" r:id="rId7"/>
-    <p:sldId id="263" r:id="rId8"/>
-    <p:sldId id="264" r:id="rId9"/>
-    <p:sldId id="266" r:id="rId10"/>
-    <p:sldId id="267" r:id="rId11"/>
-    <p:sldId id="268" r:id="rId12"/>
-    <p:sldId id="269" r:id="rId13"/>
-    <p:sldId id="270" r:id="rId14"/>
+    <p:sldId id="271" r:id="rId8"/>
+    <p:sldId id="263" r:id="rId9"/>
+    <p:sldId id="264" r:id="rId10"/>
+    <p:sldId id="266" r:id="rId11"/>
+    <p:sldId id="267" r:id="rId12"/>
+    <p:sldId id="268" r:id="rId13"/>
+    <p:sldId id="269" r:id="rId14"/>
+    <p:sldId id="270" r:id="rId15"/>
   </p:sldIdLst>
   <p:sldSz cx="9144000" cy="5143500" type="screen16x9"/>
   <p:notesSz cx="5143500" cy="9144000"/>
@@ -398,7 +399,7 @@
           <a:p>
             <a:fld id="{F7021451-1387-4CA6-816F-3879F97B5CBC}" type="slidenum">
               <a:rPr lang="en-US"/>
-              <a:t>10</a:t>
+              <a:t>11</a:t>
             </a:fld>
             <a:endParaRPr lang="en-US"/>
           </a:p>
@@ -482,7 +483,7 @@
           <a:p>
             <a:fld id="{F7021451-1387-4CA6-816F-3879F97B5CBC}" type="slidenum">
               <a:rPr lang="en-US"/>
-              <a:t>11</a:t>
+              <a:t>12</a:t>
             </a:fld>
             <a:endParaRPr lang="en-US"/>
           </a:p>
@@ -566,7 +567,7 @@
           <a:p>
             <a:fld id="{F7021451-1387-4CA6-816F-3879F97B5CBC}" type="slidenum">
               <a:rPr lang="en-US"/>
-              <a:t>12</a:t>
+              <a:t>13</a:t>
             </a:fld>
             <a:endParaRPr lang="en-US"/>
           </a:p>
@@ -650,7 +651,7 @@
           <a:p>
             <a:fld id="{F7021451-1387-4CA6-816F-3879F97B5CBC}" type="slidenum">
               <a:rPr lang="en-US"/>
-              <a:t>13</a:t>
+              <a:t>14</a:t>
             </a:fld>
             <a:endParaRPr lang="en-US"/>
           </a:p>
@@ -1154,7 +1155,7 @@
           <a:p>
             <a:fld id="{F7021451-1387-4CA6-816F-3879F97B5CBC}" type="slidenum">
               <a:rPr lang="en-US"/>
-              <a:t>7</a:t>
+              <a:t>8</a:t>
             </a:fld>
             <a:endParaRPr lang="en-US"/>
           </a:p>
@@ -1238,7 +1239,7 @@
           <a:p>
             <a:fld id="{F7021451-1387-4CA6-816F-3879F97B5CBC}" type="slidenum">
               <a:rPr lang="en-US"/>
-              <a:t>8</a:t>
+              <a:t>9</a:t>
             </a:fld>
             <a:endParaRPr lang="en-US"/>
           </a:p>
@@ -1357,7 +1358,7 @@
           <a:p>
             <a:fld id="{F7021451-1387-4CA6-816F-3879F97B5CBC}" type="slidenum">
               <a:rPr lang="en-US"/>
-              <a:t>9</a:t>
+              <a:t>10</a:t>
             </a:fld>
             <a:endParaRPr lang="en-US"/>
           </a:p>
@@ -1862,7 +1863,7 @@
                 <a:ea typeface="Calibri" pitchFamily="34" charset="-122"/>
                 <a:cs typeface="Calibri" pitchFamily="34" charset="-120"/>
               </a:rPr>
-              <a:t>TASK 3: SYSTEM MODELLING AND DESIGN</a:t>
+              <a:t>TASK 4: SYSTEM MODELLING AND DESIGN</a:t>
             </a:r>
             <a:endParaRPr lang="en-US" sz="5400" dirty="0"/>
           </a:p>
@@ -1975,6 +1976,238 @@
 </file>
 
 <file path=ppt/slides/slide10.xml><?xml version="1.0" encoding="utf-8"?>
+<p:sld xmlns:a="http://schemas.openxmlformats.org/drawingml/2006/main" xmlns:r="http://schemas.openxmlformats.org/officeDocument/2006/relationships" xmlns:p="http://schemas.openxmlformats.org/presentationml/2006/main">
+  <p:cSld name="Slide 11">
+    <p:spTree>
+      <p:nvGrpSpPr>
+        <p:cNvPr id="1" name=""/>
+        <p:cNvGrpSpPr/>
+        <p:nvPr/>
+      </p:nvGrpSpPr>
+      <p:grpSpPr>
+        <a:xfrm>
+          <a:off x="0" y="0"/>
+          <a:ext cx="0" cy="0"/>
+          <a:chOff x="0" y="0"/>
+          <a:chExt cx="0" cy="0"/>
+        </a:xfrm>
+      </p:grpSpPr>
+      <p:sp>
+        <p:nvSpPr>
+          <p:cNvPr id="2" name="Shape 0"/>
+          <p:cNvSpPr/>
+          <p:nvPr/>
+        </p:nvSpPr>
+        <p:spPr>
+          <a:xfrm>
+            <a:off x="0" y="0"/>
+            <a:ext cx="9144000" cy="658368"/>
+          </a:xfrm>
+          <a:prstGeom prst="rect">
+            <a:avLst/>
+          </a:prstGeom>
+          <a:solidFill>
+            <a:srgbClr val="1B3A5C"/>
+          </a:solidFill>
+          <a:ln w="12700">
+            <a:solidFill>
+              <a:srgbClr val="1B3A5C"/>
+            </a:solidFill>
+            <a:prstDash val="solid"/>
+          </a:ln>
+        </p:spPr>
+      </p:sp>
+      <p:sp>
+        <p:nvSpPr>
+          <p:cNvPr id="3" name="Text 1"/>
+          <p:cNvSpPr/>
+          <p:nvPr/>
+        </p:nvSpPr>
+        <p:spPr>
+          <a:xfrm>
+            <a:off x="320040" y="0"/>
+            <a:ext cx="8503920" cy="658368"/>
+          </a:xfrm>
+          <a:prstGeom prst="rect">
+            <a:avLst/>
+          </a:prstGeom>
+          <a:noFill/>
+          <a:ln/>
+        </p:spPr>
+        <p:txBody>
+          <a:bodyPr wrap="square" lIns="0" tIns="0" rIns="0" bIns="0" rtlCol="0" anchor="ctr"/>
+          <a:lstStyle/>
+          <a:p>
+            <a:pPr marL="0" indent="0">
+              <a:buNone/>
+            </a:pPr>
+            <a:r>
+              <a:rPr lang="en-US" sz="4000" b="1" dirty="0">
+                <a:solidFill>
+                  <a:srgbClr val="FFFFFF"/>
+                </a:solidFill>
+              </a:rPr>
+              <a:t>V. SEQUENCE DIAGRAM</a:t>
+            </a:r>
+            <a:endParaRPr lang="en-US" sz="4000" dirty="0"/>
+          </a:p>
+        </p:txBody>
+      </p:sp>
+      <p:sp>
+        <p:nvSpPr>
+          <p:cNvPr id="4" name="Shape 2"/>
+          <p:cNvSpPr/>
+          <p:nvPr/>
+        </p:nvSpPr>
+        <p:spPr>
+          <a:xfrm>
+            <a:off x="0" y="658368"/>
+            <a:ext cx="9144000" cy="36576"/>
+          </a:xfrm>
+          <a:prstGeom prst="rect">
+            <a:avLst/>
+          </a:prstGeom>
+          <a:solidFill>
+            <a:srgbClr val="00ACC1"/>
+          </a:solidFill>
+          <a:ln w="12700">
+            <a:solidFill>
+              <a:srgbClr val="00ACC1"/>
+            </a:solidFill>
+            <a:prstDash val="solid"/>
+          </a:ln>
+        </p:spPr>
+      </p:sp>
+      <p:sp>
+        <p:nvSpPr>
+          <p:cNvPr id="49" name="TextBox 48">
+            <a:extLst>
+              <a:ext uri="{FF2B5EF4-FFF2-40B4-BE49-F238E27FC236}">
+                <a16:creationId xmlns:a16="http://schemas.microsoft.com/office/drawing/2014/main" id="{A8E9A920-F580-D40E-0CBA-555517420483}"/>
+              </a:ext>
+            </a:extLst>
+          </p:cNvPr>
+          <p:cNvSpPr txBox="1"/>
+          <p:nvPr/>
+        </p:nvSpPr>
+        <p:spPr>
+          <a:xfrm>
+            <a:off x="222341" y="776504"/>
+            <a:ext cx="8416562" cy="646331"/>
+          </a:xfrm>
+          <a:prstGeom prst="rect">
+            <a:avLst/>
+          </a:prstGeom>
+          <a:noFill/>
+        </p:spPr>
+        <p:txBody>
+          <a:bodyPr wrap="square">
+            <a:spAutoFit/>
+          </a:bodyPr>
+          <a:lstStyle/>
+          <a:p>
+            <a:r>
+              <a:rPr lang="en-US" dirty="0"/>
+              <a:t>A </a:t>
+            </a:r>
+            <a:r>
+              <a:rPr lang="en-US" u="none" strike="noStrike" dirty="0">
+                <a:effectLst/>
+                <a:latin typeface="Google Sans"/>
+              </a:rPr>
+              <a:t>sequence diagram</a:t>
+            </a:r>
+            <a:r>
+              <a:rPr lang="en-US" dirty="0"/>
+              <a:t> is a visual tool used in software engineering and system design to show how different parts of a system interact with each other to complete a task. </a:t>
+            </a:r>
+            <a:endParaRPr lang="en-CM" dirty="0"/>
+          </a:p>
+        </p:txBody>
+      </p:sp>
+      <p:pic>
+        <p:nvPicPr>
+          <p:cNvPr id="51" name="image2.png">
+            <a:extLst>
+              <a:ext uri="{FF2B5EF4-FFF2-40B4-BE49-F238E27FC236}">
+                <a16:creationId xmlns:a16="http://schemas.microsoft.com/office/drawing/2014/main" id="{BB5E9193-5E99-B0C8-9CDF-052B09913D92}"/>
+              </a:ext>
+            </a:extLst>
+          </p:cNvPr>
+          <p:cNvPicPr/>
+          <p:nvPr/>
+        </p:nvPicPr>
+        <p:blipFill>
+          <a:blip r:embed="rId3"/>
+          <a:srcRect b="8073"/>
+          <a:stretch>
+            <a:fillRect/>
+          </a:stretch>
+        </p:blipFill>
+        <p:spPr>
+          <a:xfrm>
+            <a:off x="148045" y="1439926"/>
+            <a:ext cx="8847909" cy="3703574"/>
+          </a:xfrm>
+          <a:prstGeom prst="rect">
+            <a:avLst/>
+          </a:prstGeom>
+          <a:ln/>
+        </p:spPr>
+      </p:pic>
+      <p:sp>
+        <p:nvSpPr>
+          <p:cNvPr id="52" name="TextBox 51">
+            <a:extLst>
+              <a:ext uri="{FF2B5EF4-FFF2-40B4-BE49-F238E27FC236}">
+                <a16:creationId xmlns:a16="http://schemas.microsoft.com/office/drawing/2014/main" id="{84CB34F7-732B-2C60-FCA7-F3CEFA487B55}"/>
+              </a:ext>
+            </a:extLst>
+          </p:cNvPr>
+          <p:cNvSpPr txBox="1"/>
+          <p:nvPr/>
+        </p:nvSpPr>
+        <p:spPr>
+          <a:xfrm>
+            <a:off x="8533313" y="17091"/>
+            <a:ext cx="513805" cy="584775"/>
+          </a:xfrm>
+          <a:prstGeom prst="rect">
+            <a:avLst/>
+          </a:prstGeom>
+          <a:noFill/>
+        </p:spPr>
+        <p:txBody>
+          <a:bodyPr wrap="square" rtlCol="0">
+            <a:spAutoFit/>
+          </a:bodyPr>
+          <a:lstStyle/>
+          <a:p>
+            <a:r>
+              <a:rPr lang="fr-FR" sz="3200" b="1" dirty="0">
+                <a:solidFill>
+                  <a:schemeClr val="bg1"/>
+                </a:solidFill>
+              </a:rPr>
+              <a:t>9</a:t>
+            </a:r>
+            <a:endParaRPr lang="en-CM" sz="3200" b="1" dirty="0">
+              <a:solidFill>
+                <a:schemeClr val="bg1"/>
+              </a:solidFill>
+            </a:endParaRPr>
+          </a:p>
+        </p:txBody>
+      </p:sp>
+    </p:spTree>
+  </p:cSld>
+  <p:clrMapOvr>
+    <a:masterClrMapping/>
+  </p:clrMapOvr>
+</p:sld>
+</file>
+
+<file path=ppt/slides/slide11.xml><?xml version="1.0" encoding="utf-8"?>
 <p:sld xmlns:a="http://schemas.openxmlformats.org/drawingml/2006/main" xmlns:r="http://schemas.openxmlformats.org/officeDocument/2006/relationships" xmlns:p="http://schemas.openxmlformats.org/presentationml/2006/main">
   <p:cSld name="Slide 12">
     <p:spTree>
@@ -2366,8 +2599,8 @@
         </p:nvSpPr>
         <p:spPr>
           <a:xfrm>
-            <a:off x="8533313" y="17091"/>
-            <a:ext cx="513805" cy="584775"/>
+            <a:off x="8281851" y="17091"/>
+            <a:ext cx="765267" cy="584775"/>
           </a:xfrm>
           <a:prstGeom prst="rect">
             <a:avLst/>
@@ -2386,7 +2619,7 @@
                   <a:schemeClr val="bg1"/>
                 </a:solidFill>
               </a:rPr>
-              <a:t>9</a:t>
+              <a:t>10</a:t>
             </a:r>
             <a:endParaRPr lang="en-CM" sz="3200" b="1" dirty="0">
               <a:solidFill>
@@ -2404,7 +2637,7 @@
 </p:sld>
 </file>
 
-<file path=ppt/slides/slide11.xml><?xml version="1.0" encoding="utf-8"?>
+<file path=ppt/slides/slide12.xml><?xml version="1.0" encoding="utf-8"?>
 <p:sld xmlns:a="http://schemas.openxmlformats.org/drawingml/2006/main" xmlns:r="http://schemas.openxmlformats.org/officeDocument/2006/relationships" xmlns:p="http://schemas.openxmlformats.org/presentationml/2006/main">
   <p:cSld name="Slide 13">
     <p:spTree>
@@ -2571,7 +2804,7 @@
                   <a:schemeClr val="bg1"/>
                 </a:solidFill>
               </a:rPr>
-              <a:t>10</a:t>
+              <a:t>11</a:t>
             </a:r>
             <a:endParaRPr lang="en-CM" sz="3200" b="1" dirty="0">
               <a:solidFill>
@@ -2589,7 +2822,7 @@
 </p:sld>
 </file>
 
-<file path=ppt/slides/slide12.xml><?xml version="1.0" encoding="utf-8"?>
+<file path=ppt/slides/slide13.xml><?xml version="1.0" encoding="utf-8"?>
 <p:sld xmlns:a="http://schemas.openxmlformats.org/drawingml/2006/main" xmlns:r="http://schemas.openxmlformats.org/officeDocument/2006/relationships" xmlns:p="http://schemas.openxmlformats.org/presentationml/2006/main">
   <p:cSld name="Slide 14">
     <p:spTree>
@@ -2795,7 +3028,7 @@
                   <a:schemeClr val="bg1"/>
                 </a:solidFill>
               </a:rPr>
-              <a:t>11</a:t>
+              <a:t>12</a:t>
             </a:r>
             <a:endParaRPr lang="en-CM" sz="3200" b="1" dirty="0">
               <a:solidFill>
@@ -2813,7 +3046,7 @@
 </p:sld>
 </file>
 
-<file path=ppt/slides/slide13.xml><?xml version="1.0" encoding="utf-8"?>
+<file path=ppt/slides/slide14.xml><?xml version="1.0" encoding="utf-8"?>
 <p:sld xmlns:a="http://schemas.openxmlformats.org/drawingml/2006/main" xmlns:r="http://schemas.openxmlformats.org/officeDocument/2006/relationships" xmlns:p="http://schemas.openxmlformats.org/presentationml/2006/main">
   <p:cSld name="Slide 15">
     <p:spTree>
@@ -3331,7 +3564,7 @@
           <a:p>
             <a:r>
               <a:rPr lang="fr-FR" sz="3200" b="1" dirty="0"/>
-              <a:t>12</a:t>
+              <a:t>13</a:t>
             </a:r>
             <a:endParaRPr lang="en-CM" sz="3200" b="1" dirty="0"/>
           </a:p>
@@ -5358,36 +5591,6 @@
           </a:p>
         </p:txBody>
       </p:sp>
-      <p:pic>
-        <p:nvPicPr>
-          <p:cNvPr id="21" name="Picture 20">
-            <a:extLst>
-              <a:ext uri="{FF2B5EF4-FFF2-40B4-BE49-F238E27FC236}">
-                <a16:creationId xmlns:a16="http://schemas.microsoft.com/office/drawing/2014/main" id="{45BF2CB9-8A61-A00D-B88F-4D58EA61333C}"/>
-              </a:ext>
-            </a:extLst>
-          </p:cNvPr>
-          <p:cNvPicPr>
-            <a:picLocks noChangeAspect="1"/>
-          </p:cNvPicPr>
-          <p:nvPr/>
-        </p:nvPicPr>
-        <p:blipFill>
-          <a:blip r:embed="rId3"/>
-          <a:stretch>
-            <a:fillRect/>
-          </a:stretch>
-        </p:blipFill>
-        <p:spPr>
-          <a:xfrm>
-            <a:off x="2555330" y="770244"/>
-            <a:ext cx="7189333" cy="4373256"/>
-          </a:xfrm>
-          <a:prstGeom prst="rect">
-            <a:avLst/>
-          </a:prstGeom>
-        </p:spPr>
-      </p:pic>
       <p:sp>
         <p:nvSpPr>
           <p:cNvPr id="24" name="TextBox 23">
@@ -5468,6 +5671,41 @@
           </a:p>
         </p:txBody>
       </p:sp>
+      <p:pic>
+        <p:nvPicPr>
+          <p:cNvPr id="5" name="Picture 4" descr="IMG_256">
+            <a:extLst>
+              <a:ext uri="{FF2B5EF4-FFF2-40B4-BE49-F238E27FC236}">
+                <a16:creationId xmlns:a16="http://schemas.microsoft.com/office/drawing/2014/main" id="{F50DADD0-BD33-031B-613F-A37E984F4EA8}"/>
+              </a:ext>
+            </a:extLst>
+          </p:cNvPr>
+          <p:cNvPicPr>
+            <a:picLocks noChangeAspect="1"/>
+          </p:cNvPicPr>
+          <p:nvPr/>
+        </p:nvPicPr>
+        <p:blipFill>
+          <a:blip r:embed="rId3"/>
+          <a:srcRect t="12756"/>
+          <a:stretch>
+            <a:fillRect/>
+          </a:stretch>
+        </p:blipFill>
+        <p:spPr>
+          <a:xfrm>
+            <a:off x="2426451" y="800967"/>
+            <a:ext cx="6626109" cy="4342533"/>
+          </a:xfrm>
+          <a:prstGeom prst="rect">
+            <a:avLst/>
+          </a:prstGeom>
+          <a:noFill/>
+          <a:ln w="9525">
+            <a:noFill/>
+          </a:ln>
+        </p:spPr>
+      </p:pic>
     </p:spTree>
   </p:cSld>
   <p:clrMapOvr>
@@ -5548,7 +5786,7 @@
                   <a:srgbClr val="FFFFFF"/>
                 </a:solidFill>
               </a:rPr>
-              <a:t>DATA FLOW DIAGRAM — LEVEL 1 &amp; LEVEL 2</a:t>
+              <a:t>DATA FLOW DIAGRAM — LEVEL 1</a:t>
             </a:r>
             <a:endParaRPr lang="en-US" sz="3600" dirty="0"/>
           </a:p>
@@ -5579,153 +5817,6 @@
           </a:ln>
         </p:spPr>
       </p:sp>
-      <p:pic>
-        <p:nvPicPr>
-          <p:cNvPr id="26" name="Picture 25" descr="IMG_256">
-            <a:extLst>
-              <a:ext uri="{FF2B5EF4-FFF2-40B4-BE49-F238E27FC236}">
-                <a16:creationId xmlns:a16="http://schemas.microsoft.com/office/drawing/2014/main" id="{0E1B510E-84C1-4811-1DD8-67CB76ADBB98}"/>
-              </a:ext>
-            </a:extLst>
-          </p:cNvPr>
-          <p:cNvPicPr>
-            <a:picLocks noChangeAspect="1"/>
-          </p:cNvPicPr>
-          <p:nvPr/>
-        </p:nvPicPr>
-        <p:blipFill>
-          <a:blip r:embed="rId3"/>
-          <a:srcRect t="6537"/>
-          <a:stretch>
-            <a:fillRect/>
-          </a:stretch>
-        </p:blipFill>
-        <p:spPr>
-          <a:xfrm>
-            <a:off x="1077686" y="694944"/>
-            <a:ext cx="2612571" cy="4409977"/>
-          </a:xfrm>
-          <a:prstGeom prst="rect">
-            <a:avLst/>
-          </a:prstGeom>
-          <a:noFill/>
-          <a:ln w="9525">
-            <a:noFill/>
-          </a:ln>
-        </p:spPr>
-      </p:pic>
-      <p:pic>
-        <p:nvPicPr>
-          <p:cNvPr id="27" name="Picture 26" descr="IMG_256">
-            <a:extLst>
-              <a:ext uri="{FF2B5EF4-FFF2-40B4-BE49-F238E27FC236}">
-                <a16:creationId xmlns:a16="http://schemas.microsoft.com/office/drawing/2014/main" id="{7DE25B0C-4A8B-5BE6-98D6-81F7C1E8DB36}"/>
-              </a:ext>
-            </a:extLst>
-          </p:cNvPr>
-          <p:cNvPicPr>
-            <a:picLocks noChangeAspect="1"/>
-          </p:cNvPicPr>
-          <p:nvPr/>
-        </p:nvPicPr>
-        <p:blipFill rotWithShape="1">
-          <a:blip r:embed="rId4"/>
-          <a:srcRect t="13209"/>
-          <a:stretch>
-            <a:fillRect/>
-          </a:stretch>
-        </p:blipFill>
-        <p:spPr bwMode="auto">
-          <a:xfrm>
-            <a:off x="5835196" y="787690"/>
-            <a:ext cx="2231118" cy="4247842"/>
-          </a:xfrm>
-          <a:prstGeom prst="rect">
-            <a:avLst/>
-          </a:prstGeom>
-          <a:noFill/>
-          <a:ln>
-            <a:noFill/>
-          </a:ln>
-          <a:extLst>
-            <a:ext uri="{53640926-AAD7-44D8-BBD7-CCE9431645EC}">
-              <a14:shadowObscured xmlns:a14="http://schemas.microsoft.com/office/drawing/2010/main"/>
-            </a:ext>
-          </a:extLst>
-        </p:spPr>
-      </p:pic>
-      <p:sp>
-        <p:nvSpPr>
-          <p:cNvPr id="28" name="TextBox 27">
-            <a:extLst>
-              <a:ext uri="{FF2B5EF4-FFF2-40B4-BE49-F238E27FC236}">
-                <a16:creationId xmlns:a16="http://schemas.microsoft.com/office/drawing/2014/main" id="{61B8F896-3B27-EF26-EA49-A85CE74349AF}"/>
-              </a:ext>
-            </a:extLst>
-          </p:cNvPr>
-          <p:cNvSpPr txBox="1"/>
-          <p:nvPr/>
-        </p:nvSpPr>
-        <p:spPr>
-          <a:xfrm>
-            <a:off x="236764" y="979714"/>
-            <a:ext cx="840922" cy="369332"/>
-          </a:xfrm>
-          <a:prstGeom prst="rect">
-            <a:avLst/>
-          </a:prstGeom>
-          <a:noFill/>
-        </p:spPr>
-        <p:txBody>
-          <a:bodyPr wrap="square" rtlCol="0">
-            <a:spAutoFit/>
-          </a:bodyPr>
-          <a:lstStyle/>
-          <a:p>
-            <a:r>
-              <a:rPr lang="fr-FR" dirty="0"/>
-              <a:t>Level 1</a:t>
-            </a:r>
-            <a:endParaRPr lang="en-CM" dirty="0"/>
-          </a:p>
-        </p:txBody>
-      </p:sp>
-      <p:sp>
-        <p:nvSpPr>
-          <p:cNvPr id="29" name="TextBox 28">
-            <a:extLst>
-              <a:ext uri="{FF2B5EF4-FFF2-40B4-BE49-F238E27FC236}">
-                <a16:creationId xmlns:a16="http://schemas.microsoft.com/office/drawing/2014/main" id="{7307548E-38EC-9777-7C9E-D48694ED79A3}"/>
-              </a:ext>
-            </a:extLst>
-          </p:cNvPr>
-          <p:cNvSpPr txBox="1"/>
-          <p:nvPr/>
-        </p:nvSpPr>
-        <p:spPr>
-          <a:xfrm>
-            <a:off x="4416879" y="1102179"/>
-            <a:ext cx="938892" cy="369332"/>
-          </a:xfrm>
-          <a:prstGeom prst="rect">
-            <a:avLst/>
-          </a:prstGeom>
-          <a:noFill/>
-        </p:spPr>
-        <p:txBody>
-          <a:bodyPr wrap="square" rtlCol="0">
-            <a:spAutoFit/>
-          </a:bodyPr>
-          <a:lstStyle/>
-          <a:p>
-            <a:r>
-              <a:rPr lang="fr-FR" dirty="0"/>
-              <a:t>Level 2</a:t>
-            </a:r>
-            <a:endParaRPr lang="en-CM" dirty="0"/>
-          </a:p>
-        </p:txBody>
-      </p:sp>
       <p:sp>
         <p:nvSpPr>
           <p:cNvPr id="30" name="TextBox 29">
@@ -5740,7 +5831,7 @@
         </p:nvSpPr>
         <p:spPr>
           <a:xfrm>
-            <a:off x="8650333" y="579605"/>
+            <a:off x="8546375" y="91881"/>
             <a:ext cx="513805" cy="584775"/>
           </a:xfrm>
           <a:prstGeom prst="rect">
@@ -5755,13 +5846,56 @@
           <a:lstStyle/>
           <a:p>
             <a:r>
-              <a:rPr lang="fr-FR" sz="3200" b="1" dirty="0"/>
+              <a:rPr lang="fr-FR" sz="3200" b="1" dirty="0">
+                <a:solidFill>
+                  <a:schemeClr val="bg1"/>
+                </a:solidFill>
+              </a:rPr>
               <a:t>5</a:t>
             </a:r>
-            <a:endParaRPr lang="en-CM" sz="3200" b="1" dirty="0"/>
-          </a:p>
-        </p:txBody>
-      </p:sp>
+            <a:endParaRPr lang="en-CM" sz="3200" b="1" dirty="0">
+              <a:solidFill>
+                <a:schemeClr val="bg1"/>
+              </a:solidFill>
+            </a:endParaRPr>
+          </a:p>
+        </p:txBody>
+      </p:sp>
+      <p:pic>
+        <p:nvPicPr>
+          <p:cNvPr id="5" name="Picture 4" descr="IMG_256">
+            <a:extLst>
+              <a:ext uri="{FF2B5EF4-FFF2-40B4-BE49-F238E27FC236}">
+                <a16:creationId xmlns:a16="http://schemas.microsoft.com/office/drawing/2014/main" id="{AB439278-2A4D-709B-12CC-3C44248C5195}"/>
+              </a:ext>
+            </a:extLst>
+          </p:cNvPr>
+          <p:cNvPicPr>
+            <a:picLocks noChangeAspect="1"/>
+          </p:cNvPicPr>
+          <p:nvPr/>
+        </p:nvPicPr>
+        <p:blipFill>
+          <a:blip r:embed="rId3"/>
+          <a:srcRect l="-1" t="8447" r="25783"/>
+          <a:stretch>
+            <a:fillRect/>
+          </a:stretch>
+        </p:blipFill>
+        <p:spPr>
+          <a:xfrm>
+            <a:off x="1155972" y="579604"/>
+            <a:ext cx="6681742" cy="5518593"/>
+          </a:xfrm>
+          <a:prstGeom prst="rect">
+            <a:avLst/>
+          </a:prstGeom>
+          <a:noFill/>
+          <a:ln w="9525">
+            <a:noFill/>
+          </a:ln>
+        </p:spPr>
+      </p:pic>
     </p:spTree>
   </p:cSld>
   <p:clrMapOvr>
@@ -5771,6 +5905,188 @@
 </file>
 
 <file path=ppt/slides/slide7.xml><?xml version="1.0" encoding="utf-8"?>
+<p:sld xmlns:a="http://schemas.openxmlformats.org/drawingml/2006/main" xmlns:r="http://schemas.openxmlformats.org/officeDocument/2006/relationships" xmlns:p="http://schemas.openxmlformats.org/presentationml/2006/main">
+  <p:cSld>
+    <p:spTree>
+      <p:nvGrpSpPr>
+        <p:cNvPr id="1" name=""/>
+        <p:cNvGrpSpPr/>
+        <p:nvPr/>
+      </p:nvGrpSpPr>
+      <p:grpSpPr>
+        <a:xfrm>
+          <a:off x="0" y="0"/>
+          <a:ext cx="0" cy="0"/>
+          <a:chOff x="0" y="0"/>
+          <a:chExt cx="0" cy="0"/>
+        </a:xfrm>
+      </p:grpSpPr>
+      <p:sp>
+        <p:nvSpPr>
+          <p:cNvPr id="2" name="Shape 0">
+            <a:extLst>
+              <a:ext uri="{FF2B5EF4-FFF2-40B4-BE49-F238E27FC236}">
+                <a16:creationId xmlns:a16="http://schemas.microsoft.com/office/drawing/2014/main" id="{FD3747C3-601C-B8D3-1E15-D4F0E147A73B}"/>
+              </a:ext>
+            </a:extLst>
+          </p:cNvPr>
+          <p:cNvSpPr/>
+          <p:nvPr/>
+        </p:nvSpPr>
+        <p:spPr>
+          <a:xfrm>
+            <a:off x="0" y="0"/>
+            <a:ext cx="9144000" cy="658368"/>
+          </a:xfrm>
+          <a:prstGeom prst="rect">
+            <a:avLst/>
+          </a:prstGeom>
+          <a:solidFill>
+            <a:srgbClr val="1B3A5C"/>
+          </a:solidFill>
+          <a:ln w="12700">
+            <a:solidFill>
+              <a:srgbClr val="1B3A5C"/>
+            </a:solidFill>
+            <a:prstDash val="solid"/>
+          </a:ln>
+        </p:spPr>
+      </p:sp>
+      <p:sp>
+        <p:nvSpPr>
+          <p:cNvPr id="4" name="TextBox 3">
+            <a:extLst>
+              <a:ext uri="{FF2B5EF4-FFF2-40B4-BE49-F238E27FC236}">
+                <a16:creationId xmlns:a16="http://schemas.microsoft.com/office/drawing/2014/main" id="{5BAD935F-7446-EA32-EF3C-D6385888B36C}"/>
+              </a:ext>
+            </a:extLst>
+          </p:cNvPr>
+          <p:cNvSpPr txBox="1"/>
+          <p:nvPr/>
+        </p:nvSpPr>
+        <p:spPr>
+          <a:xfrm>
+            <a:off x="285205" y="-7993"/>
+            <a:ext cx="8484325" cy="646331"/>
+          </a:xfrm>
+          <a:prstGeom prst="rect">
+            <a:avLst/>
+          </a:prstGeom>
+          <a:noFill/>
+        </p:spPr>
+        <p:txBody>
+          <a:bodyPr wrap="square">
+            <a:spAutoFit/>
+          </a:bodyPr>
+          <a:lstStyle/>
+          <a:p>
+            <a:pPr marL="0" indent="0">
+              <a:buNone/>
+            </a:pPr>
+            <a:r>
+              <a:rPr lang="en-US" sz="3600" b="1" dirty="0">
+                <a:solidFill>
+                  <a:srgbClr val="FFFFFF"/>
+                </a:solidFill>
+              </a:rPr>
+              <a:t>DATA FLOW DIAGRAM — LEVEL 2</a:t>
+            </a:r>
+            <a:endParaRPr lang="en-US" sz="3600" dirty="0"/>
+          </a:p>
+        </p:txBody>
+      </p:sp>
+      <p:pic>
+        <p:nvPicPr>
+          <p:cNvPr id="5" name="Picture 4" descr="IMG_256">
+            <a:extLst>
+              <a:ext uri="{FF2B5EF4-FFF2-40B4-BE49-F238E27FC236}">
+                <a16:creationId xmlns:a16="http://schemas.microsoft.com/office/drawing/2014/main" id="{F6B6979D-0EAC-4576-3CCF-00F8C068DE10}"/>
+              </a:ext>
+            </a:extLst>
+          </p:cNvPr>
+          <p:cNvPicPr>
+            <a:picLocks noChangeAspect="1"/>
+          </p:cNvPicPr>
+          <p:nvPr/>
+        </p:nvPicPr>
+        <p:blipFill>
+          <a:blip r:embed="rId2"/>
+          <a:stretch>
+            <a:fillRect/>
+          </a:stretch>
+        </p:blipFill>
+        <p:spPr>
+          <a:xfrm>
+            <a:off x="537753" y="727276"/>
+            <a:ext cx="7543801" cy="4464930"/>
+          </a:xfrm>
+          <a:prstGeom prst="rect">
+            <a:avLst/>
+          </a:prstGeom>
+          <a:noFill/>
+          <a:ln w="9525">
+            <a:noFill/>
+          </a:ln>
+        </p:spPr>
+      </p:pic>
+      <p:sp>
+        <p:nvSpPr>
+          <p:cNvPr id="3" name="TextBox 2">
+            <a:extLst>
+              <a:ext uri="{FF2B5EF4-FFF2-40B4-BE49-F238E27FC236}">
+                <a16:creationId xmlns:a16="http://schemas.microsoft.com/office/drawing/2014/main" id="{61AED72D-83F5-413C-2D0C-EF5B793AFE15}"/>
+              </a:ext>
+            </a:extLst>
+          </p:cNvPr>
+          <p:cNvSpPr txBox="1"/>
+          <p:nvPr/>
+        </p:nvSpPr>
+        <p:spPr>
+          <a:xfrm>
+            <a:off x="8546375" y="91881"/>
+            <a:ext cx="513805" cy="584775"/>
+          </a:xfrm>
+          <a:prstGeom prst="rect">
+            <a:avLst/>
+          </a:prstGeom>
+          <a:noFill/>
+        </p:spPr>
+        <p:txBody>
+          <a:bodyPr wrap="square" rtlCol="0">
+            <a:spAutoFit/>
+          </a:bodyPr>
+          <a:lstStyle/>
+          <a:p>
+            <a:r>
+              <a:rPr lang="fr-FR" sz="3200" b="1" dirty="0">
+                <a:solidFill>
+                  <a:schemeClr val="bg1"/>
+                </a:solidFill>
+              </a:rPr>
+              <a:t>6</a:t>
+            </a:r>
+            <a:endParaRPr lang="en-CM" sz="3200" b="1" dirty="0">
+              <a:solidFill>
+                <a:schemeClr val="bg1"/>
+              </a:solidFill>
+            </a:endParaRPr>
+          </a:p>
+        </p:txBody>
+      </p:sp>
+    </p:spTree>
+    <p:extLst>
+      <p:ext uri="{BB962C8B-B14F-4D97-AF65-F5344CB8AC3E}">
+        <p14:creationId xmlns:p14="http://schemas.microsoft.com/office/powerpoint/2010/main" val="3852997593"/>
+      </p:ext>
+    </p:extLst>
+  </p:cSld>
+  <p:clrMapOvr>
+    <a:masterClrMapping/>
+  </p:clrMapOvr>
+</p:sld>
+</file>
+
+<file path=ppt/slides/slide8.xml><?xml version="1.0" encoding="utf-8"?>
 <p:sld xmlns:a="http://schemas.openxmlformats.org/drawingml/2006/main" xmlns:r="http://schemas.openxmlformats.org/officeDocument/2006/relationships" xmlns:p="http://schemas.openxmlformats.org/presentationml/2006/main">
   <p:cSld name="Slide 8">
     <p:spTree>
@@ -5973,6 +6289,7 @@
           </a:bodyPr>
           <a:lstStyle/>
           <a:p>
+            <a:pPr algn="ctr"/>
             <a:r>
               <a:rPr lang="en" sz="1600" kern="0" dirty="0">
                 <a:solidFill>
@@ -5986,6 +6303,7 @@
             </a:r>
           </a:p>
           <a:p>
+            <a:pPr algn="ctr"/>
             <a:endParaRPr lang="en-CM" sz="1600" dirty="0"/>
           </a:p>
         </p:txBody>
@@ -6054,6 +6372,7 @@
           </a:bodyPr>
           <a:lstStyle/>
           <a:p>
+            <a:pPr algn="ctr"/>
             <a:r>
               <a:rPr lang="en" sz="1600" kern="0" dirty="0">
                 <a:solidFill>
@@ -6119,7 +6438,7 @@
         <p:spPr>
           <a:xfrm>
             <a:off x="5819502" y="1458753"/>
-            <a:ext cx="2855867" cy="1815882"/>
+            <a:ext cx="2473779" cy="2308324"/>
           </a:xfrm>
           <a:prstGeom prst="rect">
             <a:avLst/>
@@ -6132,6 +6451,7 @@
           </a:bodyPr>
           <a:lstStyle/>
           <a:p>
+            <a:pPr algn="ctr"/>
             <a:r>
               <a:rPr lang="en" sz="1600" kern="0" dirty="0">
                 <a:solidFill>
@@ -6181,7 +6501,7 @@
                   <a:schemeClr val="bg1"/>
                 </a:solidFill>
               </a:rPr>
-              <a:t>6</a:t>
+              <a:t>7</a:t>
             </a:r>
             <a:endParaRPr lang="en-CM" sz="3200" b="1" dirty="0">
               <a:solidFill>
@@ -6199,7 +6519,7 @@
 </p:sld>
 </file>
 
-<file path=ppt/slides/slide8.xml><?xml version="1.0" encoding="utf-8"?>
+<file path=ppt/slides/slide9.xml><?xml version="1.0" encoding="utf-8"?>
 <p:sld xmlns:a="http://schemas.openxmlformats.org/drawingml/2006/main" xmlns:r="http://schemas.openxmlformats.org/officeDocument/2006/relationships" xmlns:p="http://schemas.openxmlformats.org/presentationml/2006/main">
   <p:cSld name="Slide 9">
     <p:spTree>
@@ -6345,238 +6665,6 @@
             <a:extLst>
               <a:ext uri="{FF2B5EF4-FFF2-40B4-BE49-F238E27FC236}">
                 <a16:creationId xmlns:a16="http://schemas.microsoft.com/office/drawing/2014/main" id="{DB42121B-56CE-DDFB-18DF-23B83E4C27F6}"/>
-              </a:ext>
-            </a:extLst>
-          </p:cNvPr>
-          <p:cNvSpPr txBox="1"/>
-          <p:nvPr/>
-        </p:nvSpPr>
-        <p:spPr>
-          <a:xfrm>
-            <a:off x="8533313" y="17091"/>
-            <a:ext cx="513805" cy="584775"/>
-          </a:xfrm>
-          <a:prstGeom prst="rect">
-            <a:avLst/>
-          </a:prstGeom>
-          <a:noFill/>
-        </p:spPr>
-        <p:txBody>
-          <a:bodyPr wrap="square" rtlCol="0">
-            <a:spAutoFit/>
-          </a:bodyPr>
-          <a:lstStyle/>
-          <a:p>
-            <a:r>
-              <a:rPr lang="fr-FR" sz="3200" b="1" dirty="0">
-                <a:solidFill>
-                  <a:schemeClr val="bg1"/>
-                </a:solidFill>
-              </a:rPr>
-              <a:t>7</a:t>
-            </a:r>
-            <a:endParaRPr lang="en-CM" sz="3200" b="1" dirty="0">
-              <a:solidFill>
-                <a:schemeClr val="bg1"/>
-              </a:solidFill>
-            </a:endParaRPr>
-          </a:p>
-        </p:txBody>
-      </p:sp>
-    </p:spTree>
-  </p:cSld>
-  <p:clrMapOvr>
-    <a:masterClrMapping/>
-  </p:clrMapOvr>
-</p:sld>
-</file>
-
-<file path=ppt/slides/slide9.xml><?xml version="1.0" encoding="utf-8"?>
-<p:sld xmlns:a="http://schemas.openxmlformats.org/drawingml/2006/main" xmlns:r="http://schemas.openxmlformats.org/officeDocument/2006/relationships" xmlns:p="http://schemas.openxmlformats.org/presentationml/2006/main">
-  <p:cSld name="Slide 11">
-    <p:spTree>
-      <p:nvGrpSpPr>
-        <p:cNvPr id="1" name=""/>
-        <p:cNvGrpSpPr/>
-        <p:nvPr/>
-      </p:nvGrpSpPr>
-      <p:grpSpPr>
-        <a:xfrm>
-          <a:off x="0" y="0"/>
-          <a:ext cx="0" cy="0"/>
-          <a:chOff x="0" y="0"/>
-          <a:chExt cx="0" cy="0"/>
-        </a:xfrm>
-      </p:grpSpPr>
-      <p:sp>
-        <p:nvSpPr>
-          <p:cNvPr id="2" name="Shape 0"/>
-          <p:cNvSpPr/>
-          <p:nvPr/>
-        </p:nvSpPr>
-        <p:spPr>
-          <a:xfrm>
-            <a:off x="0" y="0"/>
-            <a:ext cx="9144000" cy="658368"/>
-          </a:xfrm>
-          <a:prstGeom prst="rect">
-            <a:avLst/>
-          </a:prstGeom>
-          <a:solidFill>
-            <a:srgbClr val="1B3A5C"/>
-          </a:solidFill>
-          <a:ln w="12700">
-            <a:solidFill>
-              <a:srgbClr val="1B3A5C"/>
-            </a:solidFill>
-            <a:prstDash val="solid"/>
-          </a:ln>
-        </p:spPr>
-      </p:sp>
-      <p:sp>
-        <p:nvSpPr>
-          <p:cNvPr id="3" name="Text 1"/>
-          <p:cNvSpPr/>
-          <p:nvPr/>
-        </p:nvSpPr>
-        <p:spPr>
-          <a:xfrm>
-            <a:off x="320040" y="0"/>
-            <a:ext cx="8503920" cy="658368"/>
-          </a:xfrm>
-          <a:prstGeom prst="rect">
-            <a:avLst/>
-          </a:prstGeom>
-          <a:noFill/>
-          <a:ln/>
-        </p:spPr>
-        <p:txBody>
-          <a:bodyPr wrap="square" lIns="0" tIns="0" rIns="0" bIns="0" rtlCol="0" anchor="ctr"/>
-          <a:lstStyle/>
-          <a:p>
-            <a:pPr marL="0" indent="0">
-              <a:buNone/>
-            </a:pPr>
-            <a:r>
-              <a:rPr lang="en-US" sz="4000" b="1" dirty="0">
-                <a:solidFill>
-                  <a:srgbClr val="FFFFFF"/>
-                </a:solidFill>
-              </a:rPr>
-              <a:t>V. SEQUENCE DIAGRAM</a:t>
-            </a:r>
-            <a:endParaRPr lang="en-US" sz="4000" dirty="0"/>
-          </a:p>
-        </p:txBody>
-      </p:sp>
-      <p:sp>
-        <p:nvSpPr>
-          <p:cNvPr id="4" name="Shape 2"/>
-          <p:cNvSpPr/>
-          <p:nvPr/>
-        </p:nvSpPr>
-        <p:spPr>
-          <a:xfrm>
-            <a:off x="0" y="658368"/>
-            <a:ext cx="9144000" cy="36576"/>
-          </a:xfrm>
-          <a:prstGeom prst="rect">
-            <a:avLst/>
-          </a:prstGeom>
-          <a:solidFill>
-            <a:srgbClr val="00ACC1"/>
-          </a:solidFill>
-          <a:ln w="12700">
-            <a:solidFill>
-              <a:srgbClr val="00ACC1"/>
-            </a:solidFill>
-            <a:prstDash val="solid"/>
-          </a:ln>
-        </p:spPr>
-      </p:sp>
-      <p:sp>
-        <p:nvSpPr>
-          <p:cNvPr id="49" name="TextBox 48">
-            <a:extLst>
-              <a:ext uri="{FF2B5EF4-FFF2-40B4-BE49-F238E27FC236}">
-                <a16:creationId xmlns:a16="http://schemas.microsoft.com/office/drawing/2014/main" id="{A8E9A920-F580-D40E-0CBA-555517420483}"/>
-              </a:ext>
-            </a:extLst>
-          </p:cNvPr>
-          <p:cNvSpPr txBox="1"/>
-          <p:nvPr/>
-        </p:nvSpPr>
-        <p:spPr>
-          <a:xfrm>
-            <a:off x="222341" y="776504"/>
-            <a:ext cx="8416562" cy="646331"/>
-          </a:xfrm>
-          <a:prstGeom prst="rect">
-            <a:avLst/>
-          </a:prstGeom>
-          <a:noFill/>
-        </p:spPr>
-        <p:txBody>
-          <a:bodyPr wrap="square">
-            <a:spAutoFit/>
-          </a:bodyPr>
-          <a:lstStyle/>
-          <a:p>
-            <a:r>
-              <a:rPr lang="en-US" dirty="0"/>
-              <a:t>A </a:t>
-            </a:r>
-            <a:r>
-              <a:rPr lang="en-US" u="none" strike="noStrike" dirty="0">
-                <a:effectLst/>
-                <a:latin typeface="Google Sans"/>
-              </a:rPr>
-              <a:t>sequence diagram</a:t>
-            </a:r>
-            <a:r>
-              <a:rPr lang="en-US" dirty="0"/>
-              <a:t> is a visual tool used in software engineering and system design to show how different parts of a system interact with each other to complete a task. </a:t>
-            </a:r>
-            <a:endParaRPr lang="en-CM" dirty="0"/>
-          </a:p>
-        </p:txBody>
-      </p:sp>
-      <p:pic>
-        <p:nvPicPr>
-          <p:cNvPr id="51" name="image2.png">
-            <a:extLst>
-              <a:ext uri="{FF2B5EF4-FFF2-40B4-BE49-F238E27FC236}">
-                <a16:creationId xmlns:a16="http://schemas.microsoft.com/office/drawing/2014/main" id="{BB5E9193-5E99-B0C8-9CDF-052B09913D92}"/>
-              </a:ext>
-            </a:extLst>
-          </p:cNvPr>
-          <p:cNvPicPr/>
-          <p:nvPr/>
-        </p:nvPicPr>
-        <p:blipFill>
-          <a:blip r:embed="rId3"/>
-          <a:srcRect/>
-          <a:stretch>
-            <a:fillRect/>
-          </a:stretch>
-        </p:blipFill>
-        <p:spPr>
-          <a:xfrm>
-            <a:off x="505097" y="1422835"/>
-            <a:ext cx="8525692" cy="3861526"/>
-          </a:xfrm>
-          <a:prstGeom prst="rect">
-            <a:avLst/>
-          </a:prstGeom>
-          <a:ln/>
-        </p:spPr>
-      </p:pic>
-      <p:sp>
-        <p:nvSpPr>
-          <p:cNvPr id="52" name="TextBox 51">
-            <a:extLst>
-              <a:ext uri="{FF2B5EF4-FFF2-40B4-BE49-F238E27FC236}">
-                <a16:creationId xmlns:a16="http://schemas.microsoft.com/office/drawing/2014/main" id="{84CB34F7-732B-2C60-FCA7-F3CEFA487B55}"/>
               </a:ext>
             </a:extLst>
           </p:cNvPr>

</xml_diff>

<commit_message>
This is our task 5
</commit_message>
<xml_diff>
--- a/TASK 4/Group16 Task4.pptx
+++ b/TASK 4/Group16 Task4.pptx
@@ -6629,36 +6629,6 @@
           </a:ln>
         </p:spPr>
       </p:sp>
-      <p:pic>
-        <p:nvPicPr>
-          <p:cNvPr id="47" name="Picture 46">
-            <a:extLst>
-              <a:ext uri="{FF2B5EF4-FFF2-40B4-BE49-F238E27FC236}">
-                <a16:creationId xmlns:a16="http://schemas.microsoft.com/office/drawing/2014/main" id="{DCF4EDC2-682B-87BD-015F-EA077F013FFE}"/>
-              </a:ext>
-            </a:extLst>
-          </p:cNvPr>
-          <p:cNvPicPr>
-            <a:picLocks noChangeAspect="1"/>
-          </p:cNvPicPr>
-          <p:nvPr/>
-        </p:nvPicPr>
-        <p:blipFill>
-          <a:blip r:embed="rId3"/>
-          <a:stretch>
-            <a:fillRect/>
-          </a:stretch>
-        </p:blipFill>
-        <p:spPr>
-          <a:xfrm>
-            <a:off x="1257209" y="544966"/>
-            <a:ext cx="6090648" cy="4706656"/>
-          </a:xfrm>
-          <a:prstGeom prst="rect">
-            <a:avLst/>
-          </a:prstGeom>
-        </p:spPr>
-      </p:pic>
       <p:sp>
         <p:nvSpPr>
           <p:cNvPr id="48" name="TextBox 47">
@@ -6703,6 +6673,37 @@
           </a:p>
         </p:txBody>
       </p:sp>
+      <p:pic>
+        <p:nvPicPr>
+          <p:cNvPr id="5" name="Picture 4">
+            <a:extLst>
+              <a:ext uri="{FF2B5EF4-FFF2-40B4-BE49-F238E27FC236}">
+                <a16:creationId xmlns:a16="http://schemas.microsoft.com/office/drawing/2014/main" id="{219248DC-1063-6699-4C79-2704E0EE1DD3}"/>
+              </a:ext>
+            </a:extLst>
+          </p:cNvPr>
+          <p:cNvPicPr>
+            <a:picLocks noChangeAspect="1"/>
+          </p:cNvPicPr>
+          <p:nvPr/>
+        </p:nvPicPr>
+        <p:blipFill>
+          <a:blip r:embed="rId3"/>
+          <a:srcRect t="5449"/>
+          <a:stretch>
+            <a:fillRect/>
+          </a:stretch>
+        </p:blipFill>
+        <p:spPr>
+          <a:xfrm>
+            <a:off x="844211" y="694944"/>
+            <a:ext cx="6880292" cy="4459452"/>
+          </a:xfrm>
+          <a:prstGeom prst="rect">
+            <a:avLst/>
+          </a:prstGeom>
+        </p:spPr>
+      </p:pic>
     </p:spTree>
   </p:cSld>
   <p:clrMapOvr>

</xml_diff>